<commit_message>
Add speaking script for the PS-II presentation; name faculty mentor on slide 1
PRESENTATION_SCRIPT.md is a slide-by-slide spoken script for the 11-slide deck,
sized to roughly 14 min 40 s, with per-slide timing checkpoints, delivery notes,
ten likely examiner questions with answers, a glossary of the terms used, and
delivery tips.

All technical claims trace back to the repository: the two-phase training setup
and HSV decay scoring from INTERVIEW_PREP.md, thresholds and calibration
multipliers from backend/main.py, and the measured latency and screenshot from
a live run of the service. Organisation, industry mentor and ID remain
placeholders in both the deck and the script.

Co-Authored-By: Claude Opus 5 <noreply@anthropic.com>
Claude-Session: https://claude.ai/code/session_018ncwhtu1cDjsz724U7rPKu
</commit_message>
<xml_diff>
--- a/Fresh_Vision_PS-II_Presentation.pptx
+++ b/Fresh_Vision_PS-II_Presentation.pptx
@@ -4753,11 +4753,11 @@
             <a:r>
               <a:rPr sz="1100" b="1" i="0">
                 <a:solidFill>
-                  <a:srgbClr val="C2710C"/>
-                </a:solidFill>
-                <a:latin typeface="Calibri"/>
-              </a:rPr>
-              <a:t>[ Dr. Faculty Mentor Name ]</a:t>
+                  <a:srgbClr val="333D4A"/>
+                </a:solidFill>
+                <a:latin typeface="Calibri"/>
+              </a:rPr>
+              <a:t>Dr. Aurobindo Behera</a:t>
             </a:r>
           </a:p>
           <a:p>

</xml_diff>